<commit_message>
editing documentsfor M01 assignment
</commit_message>
<xml_diff>
--- a/Class Resources /M01 L02 Language Fundamentals.pptx
+++ b/Class Resources /M01 L02 Language Fundamentals.pptx
@@ -307,7 +307,7 @@
       </p15:sldGuideLst>
     </p:ext>
     <p:ext uri="GoogleSlidesCustomDataVersion2">
-      <go:slidesCustomData xmlns="" xmlns:mc="http://schemas.openxmlformats.org/markup-compatibility/2006" xmlns:mv="urn:schemas-microsoft-com:mac:vml" xmlns:c="http://schemas.openxmlformats.org/drawingml/2006/chart" xmlns:dgm="http://schemas.openxmlformats.org/drawingml/2006/diagram" xmlns:o="urn:schemas-microsoft-com:office:office" xmlns:v="urn:schemas-microsoft-com:vml" xmlns:pvml="urn:schemas-microsoft-com:office:powerpoint" xmlns:com="http://schemas.openxmlformats.org/drawingml/2006/compatibility" xmlns:p14="http://schemas.microsoft.com/office/powerpoint/2010/main" xmlns:p15="http://schemas.microsoft.com/office/powerpoint/2012/main" xmlns:ahyp="http://schemas.microsoft.com/office/drawing/2018/hyperlinkcolor" xmlns:go="http://customooxmlschemas.google.com/" r:id="rId43" roundtripDataSignature="AMtx7mjpIPDT06wlRtGr+uyl3ehKvjyacw=="/>
+      <go:slidesCustomData xmlns:go="http://customooxmlschemas.google.com/" xmlns:ahyp="http://schemas.microsoft.com/office/drawing/2018/hyperlinkcolor" xmlns:p15="http://schemas.microsoft.com/office/powerpoint/2012/main" xmlns:p14="http://schemas.microsoft.com/office/powerpoint/2010/main" xmlns:com="http://schemas.openxmlformats.org/drawingml/2006/compatibility" xmlns:pvml="urn:schemas-microsoft-com:office:powerpoint" xmlns:v="urn:schemas-microsoft-com:vml" xmlns:o="urn:schemas-microsoft-com:office:office" xmlns:dgm="http://schemas.openxmlformats.org/drawingml/2006/diagram" xmlns:c="http://schemas.openxmlformats.org/drawingml/2006/chart" xmlns:mv="urn:schemas-microsoft-com:mac:vml" xmlns:mc="http://schemas.openxmlformats.org/markup-compatibility/2006" xmlns="" r:id="rId43" roundtripDataSignature="AMtx7mjpIPDT06wlRtGr+uyl3ehKvjyacw=="/>
     </p:ext>
   </p:extLst>
 </p:presentation>
@@ -14947,14 +14947,14 @@
               <a:buChar char="●"/>
             </a:pPr>
             <a:r>
-              <a:rPr lang="en" sz="1400">
+              <a:rPr lang="en" sz="1400" dirty="0">
                 <a:solidFill>
                   <a:schemeClr val="dk1"/>
                 </a:solidFill>
               </a:rPr>
               <a:t>Every Java program must have at least one class. Each class has a name. By convention, class names start with an uppercase letter. In this example, the class name is . </a:t>
             </a:r>
-            <a:endParaRPr sz="1400">
+            <a:endParaRPr sz="1400" dirty="0">
               <a:solidFill>
                 <a:schemeClr val="dk1"/>
               </a:solidFill>
@@ -14978,14 +14978,14 @@
               <a:buChar char="●"/>
             </a:pPr>
             <a:r>
-              <a:rPr lang="en" sz="1400">
+              <a:rPr lang="en" sz="1400" dirty="0">
                 <a:solidFill>
                   <a:schemeClr val="dk1"/>
                 </a:solidFill>
               </a:rPr>
               <a:t>Next the main method is defined to perform the actions. In order to run a class, the class must contain a method named main. The program is executed from the main method. </a:t>
             </a:r>
-            <a:endParaRPr sz="1400">
+            <a:endParaRPr sz="1400" dirty="0">
               <a:solidFill>
                 <a:schemeClr val="dk1"/>
               </a:solidFill>
@@ -37863,7 +37863,7 @@
         </p:blipFill>
         <p:spPr>
           <a:xfrm>
-            <a:off x="4710126" y="813385"/>
+            <a:off x="4631299" y="687261"/>
             <a:ext cx="4312800" cy="1689019"/>
           </a:xfrm>
           <a:prstGeom prst="rect">
@@ -38130,7 +38130,7 @@
               <a:buNone/>
             </a:pPr>
             <a:r>
-              <a:rPr lang="en" sz="1400" b="0" i="0" u="none" strike="noStrike" cap="none">
+              <a:rPr lang="en" sz="1400" b="0" i="0" u="none" strike="noStrike" cap="none" dirty="0">
                 <a:solidFill>
                   <a:srgbClr val="303030"/>
                 </a:solidFill>
@@ -38142,7 +38142,7 @@
               <a:t>A pair of </a:t>
             </a:r>
             <a:r>
-              <a:rPr lang="en" sz="1400" b="1" i="0" u="none" strike="noStrike" cap="none">
+              <a:rPr lang="en" sz="1400" b="1" i="0" u="none" strike="noStrike" cap="none" dirty="0">
                 <a:solidFill>
                   <a:srgbClr val="303030"/>
                 </a:solidFill>
@@ -38154,7 +38154,7 @@
               <a:t>Curly brackets {}</a:t>
             </a:r>
             <a:r>
-              <a:rPr lang="en" sz="1400" b="0" i="0" u="none" strike="noStrike" cap="none">
+              <a:rPr lang="en" sz="1400" b="0" i="0" u="none" strike="noStrike" cap="none" dirty="0">
                 <a:solidFill>
                   <a:srgbClr val="303030"/>
                 </a:solidFill>
@@ -38165,7 +38165,7 @@
               </a:rPr>
               <a:t> group multiple statements into a single block. See where class HelloWorld starts and stops and main method starts and stops. Notice main method is inside the class and is indented to make it easier to read. </a:t>
             </a:r>
-            <a:endParaRPr sz="1400" b="0" i="0" u="none" strike="noStrike" cap="none">
+            <a:endParaRPr sz="1400" b="0" i="0" u="none" strike="noStrike" cap="none" dirty="0">
               <a:solidFill>
                 <a:srgbClr val="303030"/>
               </a:solidFill>
@@ -38193,7 +38193,7 @@
               <a:buFont typeface="Arial"/>
               <a:buNone/>
             </a:pPr>
-            <a:endParaRPr sz="1000" b="0" i="0" u="none" strike="noStrike" cap="none">
+            <a:endParaRPr sz="1000" b="0" i="0" u="none" strike="noStrike" cap="none" dirty="0">
               <a:solidFill>
                 <a:schemeClr val="dk1"/>
               </a:solidFill>
@@ -38222,7 +38222,7 @@
               <a:buNone/>
             </a:pPr>
             <a:r>
-              <a:rPr lang="en" sz="1400" b="0" i="0" u="none" strike="noStrike" cap="none">
+              <a:rPr lang="en" sz="1400" b="0" i="0" u="none" strike="noStrike" cap="none" dirty="0">
                 <a:solidFill>
                   <a:schemeClr val="dk1"/>
                 </a:solidFill>
@@ -38233,7 +38233,7 @@
               </a:rPr>
               <a:t>A statement represents an action or a sequence of actions. Statements in Java ends with a semicolon ;</a:t>
             </a:r>
-            <a:endParaRPr sz="1400" b="0" i="0" u="none" strike="noStrike" cap="none">
+            <a:endParaRPr sz="1400" b="0" i="0" u="none" strike="noStrike" cap="none" dirty="0">
               <a:solidFill>
                 <a:schemeClr val="dk1"/>
               </a:solidFill>
@@ -38261,7 +38261,7 @@
               <a:buFont typeface="Arial"/>
               <a:buNone/>
             </a:pPr>
-            <a:endParaRPr sz="1100" b="0" i="0" u="none" strike="noStrike" cap="none">
+            <a:endParaRPr sz="1100" b="0" i="0" u="none" strike="noStrike" cap="none" dirty="0">
               <a:solidFill>
                 <a:schemeClr val="dk1"/>
               </a:solidFill>
@@ -38290,7 +38290,7 @@
               <a:buNone/>
             </a:pPr>
             <a:r>
-              <a:rPr lang="en" sz="1400" b="0" i="0" u="none" strike="noStrike" cap="none">
+              <a:rPr lang="en" sz="1400" b="0" i="0" u="none" strike="noStrike" cap="none" dirty="0" err="1">
                 <a:solidFill>
                   <a:schemeClr val="dk1"/>
                 </a:solidFill>
@@ -38302,21 +38302,36 @@
                 <a:cs typeface="Lexend"/>
                 <a:sym typeface="Lexend"/>
               </a:rPr>
-              <a:t>println </a:t>
-            </a:r>
-            <a:r>
-              <a:rPr lang="en" sz="1400" b="0" i="0" u="none" strike="noStrike" cap="none">
+              <a:t>println</a:t>
+            </a:r>
+            <a:r>
+              <a:rPr lang="en" sz="1400" b="0" i="0" u="none" strike="noStrike" cap="none" dirty="0">
                 <a:solidFill>
                   <a:schemeClr val="dk1"/>
                 </a:solidFill>
+                <a:highlight>
+                  <a:srgbClr val="EAD1DC"/>
+                </a:highlight>
                 <a:latin typeface="Lexend"/>
                 <a:ea typeface="Lexend"/>
                 <a:cs typeface="Lexend"/>
                 <a:sym typeface="Lexend"/>
               </a:rPr>
+              <a:t> </a:t>
+            </a:r>
+            <a:r>
+              <a:rPr lang="en" sz="1400" b="0" i="0" u="none" strike="noStrike" cap="none" dirty="0">
+                <a:solidFill>
+                  <a:schemeClr val="dk1"/>
+                </a:solidFill>
+                <a:latin typeface="Lexend"/>
+                <a:ea typeface="Lexend"/>
+                <a:cs typeface="Lexend"/>
+                <a:sym typeface="Lexend"/>
+              </a:rPr>
               <a:t>is a method that is provided in the Java language to display information to the console. The String “Welcome to Java!” inside the parenthesis is the message sent for the method to print. </a:t>
             </a:r>
-            <a:endParaRPr sz="1400" b="0" i="0" u="none" strike="noStrike" cap="none">
+            <a:endParaRPr sz="1400" b="0" i="0" u="none" strike="noStrike" cap="none" dirty="0">
               <a:solidFill>
                 <a:schemeClr val="dk1"/>
               </a:solidFill>
@@ -38345,7 +38360,7 @@
               <a:buNone/>
             </a:pPr>
             <a:r>
-              <a:rPr lang="en" sz="1400" b="0" i="0" u="none" strike="noStrike" cap="none">
+              <a:rPr lang="en" sz="1400" b="0" i="0" u="none" strike="noStrike" cap="none" dirty="0">
                 <a:solidFill>
                   <a:schemeClr val="dk1"/>
                 </a:solidFill>
@@ -38360,7 +38375,7 @@
               <a:t>Comments</a:t>
             </a:r>
             <a:r>
-              <a:rPr lang="en" sz="1400" b="0" i="0" u="none" strike="noStrike" cap="none">
+              <a:rPr lang="en" sz="1400" b="0" i="0" u="none" strike="noStrike" cap="none" dirty="0">
                 <a:solidFill>
                   <a:schemeClr val="dk1"/>
                 </a:solidFill>
@@ -38371,7 +38386,7 @@
               </a:rPr>
               <a:t> are text notes in your code that the computer doesn’t run to help you and others understand what the code does. </a:t>
             </a:r>
-            <a:endParaRPr sz="1400" b="0" i="0" u="none" strike="noStrike" cap="none">
+            <a:endParaRPr sz="1400" b="0" i="0" u="none" strike="noStrike" cap="none" dirty="0">
               <a:solidFill>
                 <a:schemeClr val="dk1"/>
               </a:solidFill>

</xml_diff>